<commit_message>
make dot_in for y13v4
</commit_message>
<xml_diff>
--- a/intermodel_comparison/2013_rerun.pptx
+++ b/intermodel_comparison/2013_rerun.pptx
@@ -6,6 +6,8 @@
   </p:sldMasterIdLst>
   <p:sldIdLst>
     <p:sldId id="256" r:id="rId2"/>
+    <p:sldId id="257" r:id="rId3"/>
+    <p:sldId id="258" r:id="rId4"/>
   </p:sldIdLst>
   <p:sldSz cx="6858000" cy="6858000"/>
   <p:notesSz cx="6858000" cy="9144000"/>
@@ -104,6 +106,11 @@
       </a:defRPr>
     </a:lvl9pPr>
   </p:defaultTextStyle>
+  <p:extLst>
+    <p:ext uri="{EFAFB233-063F-42B5-8137-9DF3F51BA10A}">
+      <p15:sldGuideLst xmlns:p15="http://schemas.microsoft.com/office/powerpoint/2012/main"/>
+    </p:ext>
+  </p:extLst>
 </p:presentation>
 </file>
 
@@ -238,7 +245,7 @@
           <a:p>
             <a:fld id="{19C51E4E-4E89-46A5-811C-ABE8FC37155B}" type="datetimeFigureOut">
               <a:rPr lang="en-US" smtClean="0"/>
-              <a:t>7/30/2026</a:t>
+              <a:t>8/3/2026</a:t>
             </a:fld>
             <a:endParaRPr lang="en-US"/>
           </a:p>
@@ -408,7 +415,7 @@
           <a:p>
             <a:fld id="{19C51E4E-4E89-46A5-811C-ABE8FC37155B}" type="datetimeFigureOut">
               <a:rPr lang="en-US" smtClean="0"/>
-              <a:t>7/30/2026</a:t>
+              <a:t>8/3/2026</a:t>
             </a:fld>
             <a:endParaRPr lang="en-US"/>
           </a:p>
@@ -588,7 +595,7 @@
           <a:p>
             <a:fld id="{19C51E4E-4E89-46A5-811C-ABE8FC37155B}" type="datetimeFigureOut">
               <a:rPr lang="en-US" smtClean="0"/>
-              <a:t>7/30/2026</a:t>
+              <a:t>8/3/2026</a:t>
             </a:fld>
             <a:endParaRPr lang="en-US"/>
           </a:p>
@@ -758,7 +765,7 @@
           <a:p>
             <a:fld id="{19C51E4E-4E89-46A5-811C-ABE8FC37155B}" type="datetimeFigureOut">
               <a:rPr lang="en-US" smtClean="0"/>
-              <a:t>7/30/2026</a:t>
+              <a:t>8/3/2026</a:t>
             </a:fld>
             <a:endParaRPr lang="en-US"/>
           </a:p>
@@ -1004,7 +1011,7 @@
           <a:p>
             <a:fld id="{19C51E4E-4E89-46A5-811C-ABE8FC37155B}" type="datetimeFigureOut">
               <a:rPr lang="en-US" smtClean="0"/>
-              <a:t>7/30/2026</a:t>
+              <a:t>8/3/2026</a:t>
             </a:fld>
             <a:endParaRPr lang="en-US"/>
           </a:p>
@@ -1236,7 +1243,7 @@
           <a:p>
             <a:fld id="{19C51E4E-4E89-46A5-811C-ABE8FC37155B}" type="datetimeFigureOut">
               <a:rPr lang="en-US" smtClean="0"/>
-              <a:t>7/30/2026</a:t>
+              <a:t>8/3/2026</a:t>
             </a:fld>
             <a:endParaRPr lang="en-US"/>
           </a:p>
@@ -1603,7 +1610,7 @@
           <a:p>
             <a:fld id="{19C51E4E-4E89-46A5-811C-ABE8FC37155B}" type="datetimeFigureOut">
               <a:rPr lang="en-US" smtClean="0"/>
-              <a:t>7/30/2026</a:t>
+              <a:t>8/3/2026</a:t>
             </a:fld>
             <a:endParaRPr lang="en-US"/>
           </a:p>
@@ -1721,7 +1728,7 @@
           <a:p>
             <a:fld id="{19C51E4E-4E89-46A5-811C-ABE8FC37155B}" type="datetimeFigureOut">
               <a:rPr lang="en-US" smtClean="0"/>
-              <a:t>7/30/2026</a:t>
+              <a:t>8/3/2026</a:t>
             </a:fld>
             <a:endParaRPr lang="en-US"/>
           </a:p>
@@ -1816,7 +1823,7 @@
           <a:p>
             <a:fld id="{19C51E4E-4E89-46A5-811C-ABE8FC37155B}" type="datetimeFigureOut">
               <a:rPr lang="en-US" smtClean="0"/>
-              <a:t>7/30/2026</a:t>
+              <a:t>8/3/2026</a:t>
             </a:fld>
             <a:endParaRPr lang="en-US"/>
           </a:p>
@@ -2093,7 +2100,7 @@
           <a:p>
             <a:fld id="{19C51E4E-4E89-46A5-811C-ABE8FC37155B}" type="datetimeFigureOut">
               <a:rPr lang="en-US" smtClean="0"/>
-              <a:t>7/30/2026</a:t>
+              <a:t>8/3/2026</a:t>
             </a:fld>
             <a:endParaRPr lang="en-US"/>
           </a:p>
@@ -2350,7 +2357,7 @@
           <a:p>
             <a:fld id="{19C51E4E-4E89-46A5-811C-ABE8FC37155B}" type="datetimeFigureOut">
               <a:rPr lang="en-US" smtClean="0"/>
-              <a:t>7/30/2026</a:t>
+              <a:t>8/3/2026</a:t>
             </a:fld>
             <a:endParaRPr lang="en-US"/>
           </a:p>
@@ -2563,7 +2570,7 @@
           <a:p>
             <a:fld id="{19C51E4E-4E89-46A5-811C-ABE8FC37155B}" type="datetimeFigureOut">
               <a:rPr lang="en-US" smtClean="0"/>
-              <a:t>7/30/2026</a:t>
+              <a:t>8/3/2026</a:t>
             </a:fld>
             <a:endParaRPr lang="en-US"/>
           </a:p>
@@ -3349,6 +3356,697 @@
 </p:sld>
 </file>
 
+<file path=ppt/slides/slide2.xml><?xml version="1.0" encoding="utf-8"?>
+<p:sld xmlns:a="http://schemas.openxmlformats.org/drawingml/2006/main" xmlns:r="http://schemas.openxmlformats.org/officeDocument/2006/relationships" xmlns:p="http://schemas.openxmlformats.org/presentationml/2006/main">
+  <p:cSld>
+    <p:spTree>
+      <p:nvGrpSpPr>
+        <p:cNvPr id="1" name="">
+          <a:extLst>
+            <a:ext uri="{FF2B5EF4-FFF2-40B4-BE49-F238E27FC236}">
+              <a16:creationId xmlns:a16="http://schemas.microsoft.com/office/drawing/2014/main" id="{58D605F0-91E8-4B64-2CD1-5FE89F7055DF}"/>
+            </a:ext>
+          </a:extLst>
+        </p:cNvPr>
+        <p:cNvGrpSpPr/>
+        <p:nvPr/>
+      </p:nvGrpSpPr>
+      <p:grpSpPr>
+        <a:xfrm>
+          <a:off x="0" y="0"/>
+          <a:ext cx="0" cy="0"/>
+          <a:chOff x="0" y="0"/>
+          <a:chExt cx="0" cy="0"/>
+        </a:xfrm>
+      </p:grpSpPr>
+      <p:pic>
+        <p:nvPicPr>
+          <p:cNvPr id="9" name="Picture 8">
+            <a:extLst>
+              <a:ext uri="{FF2B5EF4-FFF2-40B4-BE49-F238E27FC236}">
+                <a16:creationId xmlns:a16="http://schemas.microsoft.com/office/drawing/2014/main" id="{6AED755A-A687-651C-8346-F753AF3E6827}"/>
+              </a:ext>
+            </a:extLst>
+          </p:cNvPr>
+          <p:cNvPicPr>
+            <a:picLocks noChangeAspect="1"/>
+          </p:cNvPicPr>
+          <p:nvPr/>
+        </p:nvPicPr>
+        <p:blipFill>
+          <a:blip r:embed="rId2">
+            <a:extLst>
+              <a:ext uri="{28A0092B-C50C-407E-A947-70E740481C1C}">
+                <a14:useLocalDpi xmlns:a14="http://schemas.microsoft.com/office/drawing/2010/main" val="0"/>
+              </a:ext>
+            </a:extLst>
+          </a:blip>
+          <a:srcRect t="12813"/>
+          <a:stretch>
+            <a:fillRect/>
+          </a:stretch>
+        </p:blipFill>
+        <p:spPr>
+          <a:xfrm>
+            <a:off x="1139753" y="1392758"/>
+            <a:ext cx="2289246" cy="1002355"/>
+          </a:xfrm>
+          <a:prstGeom prst="rect">
+            <a:avLst/>
+          </a:prstGeom>
+        </p:spPr>
+      </p:pic>
+      <p:pic>
+        <p:nvPicPr>
+          <p:cNvPr id="13" name="Picture 12">
+            <a:extLst>
+              <a:ext uri="{FF2B5EF4-FFF2-40B4-BE49-F238E27FC236}">
+                <a16:creationId xmlns:a16="http://schemas.microsoft.com/office/drawing/2014/main" id="{4AA85C66-1462-F8FB-F2E8-975215D79D3A}"/>
+              </a:ext>
+            </a:extLst>
+          </p:cNvPr>
+          <p:cNvPicPr>
+            <a:picLocks noChangeAspect="1"/>
+          </p:cNvPicPr>
+          <p:nvPr/>
+        </p:nvPicPr>
+        <p:blipFill>
+          <a:blip r:embed="rId3">
+            <a:extLst>
+              <a:ext uri="{28A0092B-C50C-407E-A947-70E740481C1C}">
+                <a14:useLocalDpi xmlns:a14="http://schemas.microsoft.com/office/drawing/2010/main" val="0"/>
+              </a:ext>
+            </a:extLst>
+          </a:blip>
+          <a:srcRect t="15122"/>
+          <a:stretch>
+            <a:fillRect/>
+          </a:stretch>
+        </p:blipFill>
+        <p:spPr>
+          <a:xfrm>
+            <a:off x="1139753" y="2331664"/>
+            <a:ext cx="2289246" cy="975797"/>
+          </a:xfrm>
+          <a:prstGeom prst="rect">
+            <a:avLst/>
+          </a:prstGeom>
+        </p:spPr>
+      </p:pic>
+      <p:pic>
+        <p:nvPicPr>
+          <p:cNvPr id="15" name="Picture 14">
+            <a:extLst>
+              <a:ext uri="{FF2B5EF4-FFF2-40B4-BE49-F238E27FC236}">
+                <a16:creationId xmlns:a16="http://schemas.microsoft.com/office/drawing/2014/main" id="{570853EE-2ADF-6DCF-DFA0-7A29E70EB70C}"/>
+              </a:ext>
+            </a:extLst>
+          </p:cNvPr>
+          <p:cNvPicPr>
+            <a:picLocks noChangeAspect="1"/>
+          </p:cNvPicPr>
+          <p:nvPr/>
+        </p:nvPicPr>
+        <p:blipFill>
+          <a:blip r:embed="rId4">
+            <a:extLst>
+              <a:ext uri="{28A0092B-C50C-407E-A947-70E740481C1C}">
+                <a14:useLocalDpi xmlns:a14="http://schemas.microsoft.com/office/drawing/2010/main" val="0"/>
+              </a:ext>
+            </a:extLst>
+          </a:blip>
+          <a:srcRect t="14322"/>
+          <a:stretch>
+            <a:fillRect/>
+          </a:stretch>
+        </p:blipFill>
+        <p:spPr>
+          <a:xfrm>
+            <a:off x="3412444" y="2326381"/>
+            <a:ext cx="2289247" cy="984663"/>
+          </a:xfrm>
+          <a:prstGeom prst="rect">
+            <a:avLst/>
+          </a:prstGeom>
+        </p:spPr>
+      </p:pic>
+      <p:pic>
+        <p:nvPicPr>
+          <p:cNvPr id="17" name="Picture 16">
+            <a:extLst>
+              <a:ext uri="{FF2B5EF4-FFF2-40B4-BE49-F238E27FC236}">
+                <a16:creationId xmlns:a16="http://schemas.microsoft.com/office/drawing/2014/main" id="{32DFA409-D363-2D91-16F4-C150BE4B8A95}"/>
+              </a:ext>
+            </a:extLst>
+          </p:cNvPr>
+          <p:cNvPicPr>
+            <a:picLocks noChangeAspect="1"/>
+          </p:cNvPicPr>
+          <p:nvPr/>
+        </p:nvPicPr>
+        <p:blipFill>
+          <a:blip r:embed="rId5">
+            <a:extLst>
+              <a:ext uri="{28A0092B-C50C-407E-A947-70E740481C1C}">
+                <a14:useLocalDpi xmlns:a14="http://schemas.microsoft.com/office/drawing/2010/main" val="0"/>
+              </a:ext>
+            </a:extLst>
+          </a:blip>
+          <a:srcRect t="14268"/>
+          <a:stretch>
+            <a:fillRect/>
+          </a:stretch>
+        </p:blipFill>
+        <p:spPr>
+          <a:xfrm>
+            <a:off x="1151611" y="3247593"/>
+            <a:ext cx="2289246" cy="985618"/>
+          </a:xfrm>
+          <a:prstGeom prst="rect">
+            <a:avLst/>
+          </a:prstGeom>
+        </p:spPr>
+      </p:pic>
+      <p:pic>
+        <p:nvPicPr>
+          <p:cNvPr id="19" name="Picture 18">
+            <a:extLst>
+              <a:ext uri="{FF2B5EF4-FFF2-40B4-BE49-F238E27FC236}">
+                <a16:creationId xmlns:a16="http://schemas.microsoft.com/office/drawing/2014/main" id="{263FA9DD-575E-0DDE-529F-044A6E6CD5E7}"/>
+              </a:ext>
+            </a:extLst>
+          </p:cNvPr>
+          <p:cNvPicPr>
+            <a:picLocks noChangeAspect="1"/>
+          </p:cNvPicPr>
+          <p:nvPr/>
+        </p:nvPicPr>
+        <p:blipFill>
+          <a:blip r:embed="rId6">
+            <a:extLst>
+              <a:ext uri="{28A0092B-C50C-407E-A947-70E740481C1C}">
+                <a14:useLocalDpi xmlns:a14="http://schemas.microsoft.com/office/drawing/2010/main" val="0"/>
+              </a:ext>
+            </a:extLst>
+          </a:blip>
+          <a:srcRect t="14498"/>
+          <a:stretch>
+            <a:fillRect/>
+          </a:stretch>
+        </p:blipFill>
+        <p:spPr>
+          <a:xfrm>
+            <a:off x="3424303" y="3247595"/>
+            <a:ext cx="2293945" cy="984663"/>
+          </a:xfrm>
+          <a:prstGeom prst="rect">
+            <a:avLst/>
+          </a:prstGeom>
+        </p:spPr>
+      </p:pic>
+      <p:pic>
+        <p:nvPicPr>
+          <p:cNvPr id="3" name="Picture 2">
+            <a:extLst>
+              <a:ext uri="{FF2B5EF4-FFF2-40B4-BE49-F238E27FC236}">
+                <a16:creationId xmlns:a16="http://schemas.microsoft.com/office/drawing/2014/main" id="{7A95BD2C-35C4-6DB6-644C-67F8E745CD78}"/>
+              </a:ext>
+            </a:extLst>
+          </p:cNvPr>
+          <p:cNvPicPr>
+            <a:picLocks noChangeAspect="1"/>
+          </p:cNvPicPr>
+          <p:nvPr/>
+        </p:nvPicPr>
+        <p:blipFill>
+          <a:blip r:embed="rId7">
+            <a:extLst>
+              <a:ext uri="{28A0092B-C50C-407E-A947-70E740481C1C}">
+                <a14:useLocalDpi xmlns:a14="http://schemas.microsoft.com/office/drawing/2010/main" val="0"/>
+              </a:ext>
+            </a:extLst>
+          </a:blip>
+          <a:stretch>
+            <a:fillRect/>
+          </a:stretch>
+        </p:blipFill>
+        <p:spPr>
+          <a:xfrm>
+            <a:off x="1151611" y="284740"/>
+            <a:ext cx="2289248" cy="1149653"/>
+          </a:xfrm>
+          <a:prstGeom prst="rect">
+            <a:avLst/>
+          </a:prstGeom>
+        </p:spPr>
+      </p:pic>
+      <p:pic>
+        <p:nvPicPr>
+          <p:cNvPr id="6" name="Picture 5">
+            <a:extLst>
+              <a:ext uri="{FF2B5EF4-FFF2-40B4-BE49-F238E27FC236}">
+                <a16:creationId xmlns:a16="http://schemas.microsoft.com/office/drawing/2014/main" id="{028425F6-B5B4-6946-76C9-7F03A158F074}"/>
+              </a:ext>
+            </a:extLst>
+          </p:cNvPr>
+          <p:cNvPicPr>
+            <a:picLocks noChangeAspect="1"/>
+          </p:cNvPicPr>
+          <p:nvPr/>
+        </p:nvPicPr>
+        <p:blipFill>
+          <a:blip r:embed="rId8">
+            <a:extLst>
+              <a:ext uri="{28A0092B-C50C-407E-A947-70E740481C1C}">
+                <a14:useLocalDpi xmlns:a14="http://schemas.microsoft.com/office/drawing/2010/main" val="0"/>
+              </a:ext>
+            </a:extLst>
+          </a:blip>
+          <a:stretch>
+            <a:fillRect/>
+          </a:stretch>
+        </p:blipFill>
+        <p:spPr>
+          <a:xfrm>
+            <a:off x="3424303" y="278748"/>
+            <a:ext cx="2289246" cy="1149263"/>
+          </a:xfrm>
+          <a:prstGeom prst="rect">
+            <a:avLst/>
+          </a:prstGeom>
+        </p:spPr>
+      </p:pic>
+      <p:pic>
+        <p:nvPicPr>
+          <p:cNvPr id="10" name="Picture 9">
+            <a:extLst>
+              <a:ext uri="{FF2B5EF4-FFF2-40B4-BE49-F238E27FC236}">
+                <a16:creationId xmlns:a16="http://schemas.microsoft.com/office/drawing/2014/main" id="{88FFE6EC-F99D-6C29-3056-BF62265DBF49}"/>
+              </a:ext>
+            </a:extLst>
+          </p:cNvPr>
+          <p:cNvPicPr>
+            <a:picLocks noChangeAspect="1"/>
+          </p:cNvPicPr>
+          <p:nvPr/>
+        </p:nvPicPr>
+        <p:blipFill>
+          <a:blip r:embed="rId9">
+            <a:extLst>
+              <a:ext uri="{28A0092B-C50C-407E-A947-70E740481C1C}">
+                <a14:useLocalDpi xmlns:a14="http://schemas.microsoft.com/office/drawing/2010/main" val="0"/>
+              </a:ext>
+            </a:extLst>
+          </a:blip>
+          <a:srcRect t="13645"/>
+          <a:stretch>
+            <a:fillRect/>
+          </a:stretch>
+        </p:blipFill>
+        <p:spPr>
+          <a:xfrm>
+            <a:off x="1145681" y="1362822"/>
+            <a:ext cx="2289248" cy="992783"/>
+          </a:xfrm>
+          <a:prstGeom prst="rect">
+            <a:avLst/>
+          </a:prstGeom>
+        </p:spPr>
+      </p:pic>
+      <p:pic>
+        <p:nvPicPr>
+          <p:cNvPr id="14" name="Picture 13">
+            <a:extLst>
+              <a:ext uri="{FF2B5EF4-FFF2-40B4-BE49-F238E27FC236}">
+                <a16:creationId xmlns:a16="http://schemas.microsoft.com/office/drawing/2014/main" id="{80BE6A0B-F7CB-222D-6CC4-625B31A8EBDA}"/>
+              </a:ext>
+            </a:extLst>
+          </p:cNvPr>
+          <p:cNvPicPr>
+            <a:picLocks noChangeAspect="1"/>
+          </p:cNvPicPr>
+          <p:nvPr/>
+        </p:nvPicPr>
+        <p:blipFill>
+          <a:blip r:embed="rId10">
+            <a:extLst>
+              <a:ext uri="{28A0092B-C50C-407E-A947-70E740481C1C}">
+                <a14:useLocalDpi xmlns:a14="http://schemas.microsoft.com/office/drawing/2010/main" val="0"/>
+              </a:ext>
+            </a:extLst>
+          </a:blip>
+          <a:srcRect t="13615" b="1"/>
+          <a:stretch>
+            <a:fillRect/>
+          </a:stretch>
+        </p:blipFill>
+        <p:spPr>
+          <a:xfrm>
+            <a:off x="3431525" y="1365818"/>
+            <a:ext cx="2289248" cy="992783"/>
+          </a:xfrm>
+          <a:prstGeom prst="rect">
+            <a:avLst/>
+          </a:prstGeom>
+        </p:spPr>
+      </p:pic>
+      <p:pic>
+        <p:nvPicPr>
+          <p:cNvPr id="18" name="Picture 17">
+            <a:extLst>
+              <a:ext uri="{FF2B5EF4-FFF2-40B4-BE49-F238E27FC236}">
+                <a16:creationId xmlns:a16="http://schemas.microsoft.com/office/drawing/2014/main" id="{13CC0C3B-AD85-1A25-498C-FC3D20194FF3}"/>
+              </a:ext>
+            </a:extLst>
+          </p:cNvPr>
+          <p:cNvPicPr>
+            <a:picLocks noChangeAspect="1"/>
+          </p:cNvPicPr>
+          <p:nvPr/>
+        </p:nvPicPr>
+        <p:blipFill>
+          <a:blip r:embed="rId11">
+            <a:extLst>
+              <a:ext uri="{28A0092B-C50C-407E-A947-70E740481C1C}">
+                <a14:useLocalDpi xmlns:a14="http://schemas.microsoft.com/office/drawing/2010/main" val="0"/>
+              </a:ext>
+            </a:extLst>
+          </a:blip>
+          <a:srcRect t="13097"/>
+          <a:stretch>
+            <a:fillRect/>
+          </a:stretch>
+        </p:blipFill>
+        <p:spPr>
+          <a:xfrm>
+            <a:off x="1150317" y="2292864"/>
+            <a:ext cx="2299351" cy="1003491"/>
+          </a:xfrm>
+          <a:prstGeom prst="rect">
+            <a:avLst/>
+          </a:prstGeom>
+        </p:spPr>
+      </p:pic>
+      <p:pic>
+        <p:nvPicPr>
+          <p:cNvPr id="22" name="Picture 21">
+            <a:extLst>
+              <a:ext uri="{FF2B5EF4-FFF2-40B4-BE49-F238E27FC236}">
+                <a16:creationId xmlns:a16="http://schemas.microsoft.com/office/drawing/2014/main" id="{29346083-5B00-D6FB-4ADC-D1AEF7E7BC48}"/>
+              </a:ext>
+            </a:extLst>
+          </p:cNvPr>
+          <p:cNvPicPr>
+            <a:picLocks noChangeAspect="1"/>
+          </p:cNvPicPr>
+          <p:nvPr/>
+        </p:nvPicPr>
+        <p:blipFill>
+          <a:blip r:embed="rId12">
+            <a:extLst>
+              <a:ext uri="{28A0092B-C50C-407E-A947-70E740481C1C}">
+                <a14:useLocalDpi xmlns:a14="http://schemas.microsoft.com/office/drawing/2010/main" val="0"/>
+              </a:ext>
+            </a:extLst>
+          </a:blip>
+          <a:srcRect t="13538"/>
+          <a:stretch>
+            <a:fillRect/>
+          </a:stretch>
+        </p:blipFill>
+        <p:spPr>
+          <a:xfrm>
+            <a:off x="3436002" y="2298055"/>
+            <a:ext cx="2289247" cy="993665"/>
+          </a:xfrm>
+          <a:prstGeom prst="rect">
+            <a:avLst/>
+          </a:prstGeom>
+        </p:spPr>
+      </p:pic>
+      <p:pic>
+        <p:nvPicPr>
+          <p:cNvPr id="25" name="Picture 24">
+            <a:extLst>
+              <a:ext uri="{FF2B5EF4-FFF2-40B4-BE49-F238E27FC236}">
+                <a16:creationId xmlns:a16="http://schemas.microsoft.com/office/drawing/2014/main" id="{7E0732DB-940C-46EE-5319-CCB1E3A3754B}"/>
+              </a:ext>
+            </a:extLst>
+          </p:cNvPr>
+          <p:cNvPicPr>
+            <a:picLocks noChangeAspect="1"/>
+          </p:cNvPicPr>
+          <p:nvPr/>
+        </p:nvPicPr>
+        <p:blipFill>
+          <a:blip r:embed="rId13">
+            <a:extLst>
+              <a:ext uri="{28A0092B-C50C-407E-A947-70E740481C1C}">
+                <a14:useLocalDpi xmlns:a14="http://schemas.microsoft.com/office/drawing/2010/main" val="0"/>
+              </a:ext>
+            </a:extLst>
+          </a:blip>
+          <a:srcRect t="12904"/>
+          <a:stretch>
+            <a:fillRect/>
+          </a:stretch>
+        </p:blipFill>
+        <p:spPr>
+          <a:xfrm>
+            <a:off x="1156661" y="3221862"/>
+            <a:ext cx="2289248" cy="1001310"/>
+          </a:xfrm>
+          <a:prstGeom prst="rect">
+            <a:avLst/>
+          </a:prstGeom>
+        </p:spPr>
+      </p:pic>
+      <p:pic>
+        <p:nvPicPr>
+          <p:cNvPr id="27" name="Picture 26">
+            <a:extLst>
+              <a:ext uri="{FF2B5EF4-FFF2-40B4-BE49-F238E27FC236}">
+                <a16:creationId xmlns:a16="http://schemas.microsoft.com/office/drawing/2014/main" id="{A93B6329-5ACA-F396-E541-9C5F81887C83}"/>
+              </a:ext>
+            </a:extLst>
+          </p:cNvPr>
+          <p:cNvPicPr>
+            <a:picLocks noChangeAspect="1"/>
+          </p:cNvPicPr>
+          <p:nvPr/>
+        </p:nvPicPr>
+        <p:blipFill>
+          <a:blip r:embed="rId14">
+            <a:extLst>
+              <a:ext uri="{28A0092B-C50C-407E-A947-70E740481C1C}">
+                <a14:useLocalDpi xmlns:a14="http://schemas.microsoft.com/office/drawing/2010/main" val="0"/>
+              </a:ext>
+            </a:extLst>
+          </a:blip>
+          <a:srcRect t="13539"/>
+          <a:stretch>
+            <a:fillRect/>
+          </a:stretch>
+        </p:blipFill>
+        <p:spPr>
+          <a:xfrm>
+            <a:off x="3428987" y="3231137"/>
+            <a:ext cx="2289246" cy="993665"/>
+          </a:xfrm>
+          <a:prstGeom prst="rect">
+            <a:avLst/>
+          </a:prstGeom>
+        </p:spPr>
+      </p:pic>
+      <p:pic>
+        <p:nvPicPr>
+          <p:cNvPr id="29" name="Picture 28">
+            <a:extLst>
+              <a:ext uri="{FF2B5EF4-FFF2-40B4-BE49-F238E27FC236}">
+                <a16:creationId xmlns:a16="http://schemas.microsoft.com/office/drawing/2014/main" id="{DAD85AA2-5B7D-124C-C9AA-F67A37673244}"/>
+              </a:ext>
+            </a:extLst>
+          </p:cNvPr>
+          <p:cNvPicPr>
+            <a:picLocks noChangeAspect="1"/>
+          </p:cNvPicPr>
+          <p:nvPr/>
+        </p:nvPicPr>
+        <p:blipFill>
+          <a:blip r:embed="rId15">
+            <a:extLst>
+              <a:ext uri="{28A0092B-C50C-407E-A947-70E740481C1C}">
+                <a14:useLocalDpi xmlns:a14="http://schemas.microsoft.com/office/drawing/2010/main" val="0"/>
+              </a:ext>
+            </a:extLst>
+          </a:blip>
+          <a:srcRect t="14716"/>
+          <a:stretch>
+            <a:fillRect/>
+          </a:stretch>
+        </p:blipFill>
+        <p:spPr>
+          <a:xfrm>
+            <a:off x="1160420" y="4164192"/>
+            <a:ext cx="2289248" cy="980461"/>
+          </a:xfrm>
+          <a:prstGeom prst="rect">
+            <a:avLst/>
+          </a:prstGeom>
+        </p:spPr>
+      </p:pic>
+      <p:pic>
+        <p:nvPicPr>
+          <p:cNvPr id="31" name="Picture 30">
+            <a:extLst>
+              <a:ext uri="{FF2B5EF4-FFF2-40B4-BE49-F238E27FC236}">
+                <a16:creationId xmlns:a16="http://schemas.microsoft.com/office/drawing/2014/main" id="{6554534D-E775-1534-D584-0FD6FE65A97E}"/>
+              </a:ext>
+            </a:extLst>
+          </p:cNvPr>
+          <p:cNvPicPr>
+            <a:picLocks noChangeAspect="1"/>
+          </p:cNvPicPr>
+          <p:nvPr/>
+        </p:nvPicPr>
+        <p:blipFill>
+          <a:blip r:embed="rId16">
+            <a:extLst>
+              <a:ext uri="{28A0092B-C50C-407E-A947-70E740481C1C}">
+                <a14:useLocalDpi xmlns:a14="http://schemas.microsoft.com/office/drawing/2010/main" val="0"/>
+              </a:ext>
+            </a:extLst>
+          </a:blip>
+          <a:srcRect t="13716"/>
+          <a:stretch>
+            <a:fillRect/>
+          </a:stretch>
+        </p:blipFill>
+        <p:spPr>
+          <a:xfrm>
+            <a:off x="3433750" y="4150988"/>
+            <a:ext cx="2293946" cy="993665"/>
+          </a:xfrm>
+          <a:prstGeom prst="rect">
+            <a:avLst/>
+          </a:prstGeom>
+        </p:spPr>
+      </p:pic>
+    </p:spTree>
+    <p:extLst>
+      <p:ext uri="{BB962C8B-B14F-4D97-AF65-F5344CB8AC3E}">
+        <p14:creationId xmlns:p14="http://schemas.microsoft.com/office/powerpoint/2010/main" val="1863402791"/>
+      </p:ext>
+    </p:extLst>
+  </p:cSld>
+  <p:clrMapOvr>
+    <a:masterClrMapping/>
+  </p:clrMapOvr>
+</p:sld>
+</file>
+
+<file path=ppt/slides/slide3.xml><?xml version="1.0" encoding="utf-8"?>
+<p:sld xmlns:a="http://schemas.openxmlformats.org/drawingml/2006/main" xmlns:r="http://schemas.openxmlformats.org/officeDocument/2006/relationships" xmlns:p="http://schemas.openxmlformats.org/presentationml/2006/main">
+  <p:cSld>
+    <p:spTree>
+      <p:nvGrpSpPr>
+        <p:cNvPr id="1" name=""/>
+        <p:cNvGrpSpPr/>
+        <p:nvPr/>
+      </p:nvGrpSpPr>
+      <p:grpSpPr>
+        <a:xfrm>
+          <a:off x="0" y="0"/>
+          <a:ext cx="0" cy="0"/>
+          <a:chOff x="0" y="0"/>
+          <a:chExt cx="0" cy="0"/>
+        </a:xfrm>
+      </p:grpSpPr>
+      <p:pic>
+        <p:nvPicPr>
+          <p:cNvPr id="5" name="Picture 4">
+            <a:extLst>
+              <a:ext uri="{FF2B5EF4-FFF2-40B4-BE49-F238E27FC236}">
+                <a16:creationId xmlns:a16="http://schemas.microsoft.com/office/drawing/2014/main" id="{E810EB4F-6139-A54D-B0B4-0620C83C9A8F}"/>
+              </a:ext>
+            </a:extLst>
+          </p:cNvPr>
+          <p:cNvPicPr>
+            <a:picLocks noChangeAspect="1"/>
+          </p:cNvPicPr>
+          <p:nvPr/>
+        </p:nvPicPr>
+        <p:blipFill>
+          <a:blip r:embed="rId2">
+            <a:extLst>
+              <a:ext uri="{28A0092B-C50C-407E-A947-70E740481C1C}">
+                <a14:useLocalDpi xmlns:a14="http://schemas.microsoft.com/office/drawing/2010/main" val="0"/>
+              </a:ext>
+            </a:extLst>
+          </a:blip>
+          <a:stretch>
+            <a:fillRect/>
+          </a:stretch>
+        </p:blipFill>
+        <p:spPr>
+          <a:xfrm>
+            <a:off x="2729732" y="992869"/>
+            <a:ext cx="3890143" cy="3802970"/>
+          </a:xfrm>
+          <a:prstGeom prst="rect">
+            <a:avLst/>
+          </a:prstGeom>
+        </p:spPr>
+      </p:pic>
+      <p:pic>
+        <p:nvPicPr>
+          <p:cNvPr id="7" name="Picture 6">
+            <a:extLst>
+              <a:ext uri="{FF2B5EF4-FFF2-40B4-BE49-F238E27FC236}">
+                <a16:creationId xmlns:a16="http://schemas.microsoft.com/office/drawing/2014/main" id="{DF74852F-81AB-6F41-EAA9-50B51D9C8996}"/>
+              </a:ext>
+            </a:extLst>
+          </p:cNvPr>
+          <p:cNvPicPr>
+            <a:picLocks noChangeAspect="1"/>
+          </p:cNvPicPr>
+          <p:nvPr/>
+        </p:nvPicPr>
+        <p:blipFill>
+          <a:blip r:embed="rId3">
+            <a:extLst>
+              <a:ext uri="{28A0092B-C50C-407E-A947-70E740481C1C}">
+                <a14:useLocalDpi xmlns:a14="http://schemas.microsoft.com/office/drawing/2010/main" val="0"/>
+              </a:ext>
+            </a:extLst>
+          </a:blip>
+          <a:stretch>
+            <a:fillRect/>
+          </a:stretch>
+        </p:blipFill>
+        <p:spPr>
+          <a:xfrm>
+            <a:off x="773660" y="1471613"/>
+            <a:ext cx="1855369" cy="2547938"/>
+          </a:xfrm>
+          <a:prstGeom prst="rect">
+            <a:avLst/>
+          </a:prstGeom>
+        </p:spPr>
+      </p:pic>
+    </p:spTree>
+    <p:extLst>
+      <p:ext uri="{BB962C8B-B14F-4D97-AF65-F5344CB8AC3E}">
+        <p14:creationId xmlns:p14="http://schemas.microsoft.com/office/powerpoint/2010/main" val="3418957530"/>
+      </p:ext>
+    </p:extLst>
+  </p:cSld>
+  <p:clrMapOvr>
+    <a:masterClrMapping/>
+  </p:clrMapOvr>
+</p:sld>
+</file>
+
 <file path=ppt/theme/theme1.xml><?xml version="1.0" encoding="utf-8"?>
 <a:theme xmlns:a="http://schemas.openxmlformats.org/drawingml/2006/main" name="Office Theme">
   <a:themeElements>

</xml_diff>